<commit_message>
docs: put system architecture on the SIH technical-approach slide.
SIH allows only six slides, so the control/data plane and issuers belong there rather than extra HLD slides.

Co-authored-by: Cursor <cursoragent@cursor.com>
</commit_message>
<xml_diff>
--- a/docs/demo/Samanvay-SIH2026-IDEA.pptx
+++ b/docs/demo/Samanvay-SIH2026-IDEA.pptx
@@ -7121,8 +7121,8 @@
         </p:nvSpPr>
         <p:spPr>
           <a:xfrm>
-            <a:off x="411480" y="1078992"/>
-            <a:ext cx="11338560" cy="256032"/>
+            <a:off x="347472" y="1024128"/>
+            <a:ext cx="11430000" cy="219456"/>
           </a:xfrm>
           <a:prstGeom prst="rect">
             <a:avLst/>
@@ -7139,13 +7139,13 @@
               </a:spcAft>
             </a:pPr>
             <a:r>
-              <a:rPr sz="1300" b="1">
+              <a:rPr sz="1200" b="1">
                 <a:solidFill>
                   <a:srgbClr val="C4561A"/>
                 </a:solidFill>
                 <a:latin typeface="Arial"/>
               </a:rPr>
-              <a:t>Stack (working prototype on this laptop)</a:t>
+              <a:t>Stack  ·  Java 21 / Spring Boot 4 / Modulith  ·  Postgres 16  ·  BPMN 2.0  ·  Keycloak  ·  Resilience4j  ·  REST · SOAP · SFTP · JDBC</a:t>
             </a:r>
           </a:p>
         </p:txBody>
@@ -7158,8 +7158,8 @@
         </p:nvSpPr>
         <p:spPr>
           <a:xfrm>
-            <a:off x="411480" y="1353312"/>
-            <a:ext cx="1783080" cy="713232"/>
+            <a:off x="347472" y="1261872"/>
+            <a:ext cx="3657600" cy="530352"/>
           </a:xfrm>
           <a:prstGeom prst="roundRect">
             <a:avLst>
@@ -7205,8 +7205,8 @@
         </p:nvSpPr>
         <p:spPr>
           <a:xfrm>
-            <a:off x="484632" y="1426464"/>
-            <a:ext cx="1673352" cy="347472"/>
+            <a:off x="402336" y="1307592"/>
+            <a:ext cx="3566160" cy="256032"/>
           </a:xfrm>
           <a:prstGeom prst="rect">
             <a:avLst/>
@@ -7229,7 +7229,7 @@
                 </a:solidFill>
                 <a:latin typeface="Arial"/>
               </a:rPr>
-              <a:t>Java 21 · Boot 4</a:t>
+              <a:t>Scholarship</a:t>
             </a:r>
           </a:p>
         </p:txBody>
@@ -7242,8 +7242,8 @@
         </p:nvSpPr>
         <p:spPr>
           <a:xfrm>
-            <a:off x="484632" y="1737360"/>
-            <a:ext cx="1673352" cy="256032"/>
+            <a:off x="402336" y="1517904"/>
+            <a:ext cx="3566160" cy="256032"/>
           </a:xfrm>
           <a:prstGeom prst="rect">
             <a:avLst/>
@@ -7260,13 +7260,13 @@
               </a:spcAft>
             </a:pPr>
             <a:r>
-              <a:rPr sz="1000" b="0">
+              <a:rPr sz="900" b="0">
                 <a:solidFill>
                   <a:srgbClr val="3D4A54"/>
                 </a:solidFill>
                 <a:latin typeface="Arial"/>
               </a:rPr>
-              <a:t>Spring Modulith core</a:t>
+              <a:t>Revenue · Education · DBT</a:t>
             </a:r>
           </a:p>
         </p:txBody>
@@ -7279,8 +7279,8 @@
         </p:nvSpPr>
         <p:spPr>
           <a:xfrm>
-            <a:off x="2331720" y="1353312"/>
-            <a:ext cx="1783080" cy="713232"/>
+            <a:off x="4187952" y="1261872"/>
+            <a:ext cx="3657600" cy="530352"/>
           </a:xfrm>
           <a:prstGeom prst="roundRect">
             <a:avLst>
@@ -7326,8 +7326,8 @@
         </p:nvSpPr>
         <p:spPr>
           <a:xfrm>
-            <a:off x="2404872" y="1426464"/>
-            <a:ext cx="1673352" cy="347472"/>
+            <a:off x="4242816" y="1307592"/>
+            <a:ext cx="3566160" cy="256032"/>
           </a:xfrm>
           <a:prstGeom prst="rect">
             <a:avLst/>
@@ -7350,7 +7350,7 @@
                 </a:solidFill>
                 <a:latin typeface="Arial"/>
               </a:rPr>
-              <a:t>Postgres 16</a:t>
+              <a:t>Licence / NOC</a:t>
             </a:r>
           </a:p>
         </p:txBody>
@@ -7363,8 +7363,8 @@
         </p:nvSpPr>
         <p:spPr>
           <a:xfrm>
-            <a:off x="2404872" y="1737360"/>
-            <a:ext cx="1673352" cy="256032"/>
+            <a:off x="4242816" y="1517904"/>
+            <a:ext cx="3566160" cy="256032"/>
           </a:xfrm>
           <a:prstGeom prst="rect">
             <a:avLst/>
@@ -7381,13 +7381,13 @@
               </a:spcAft>
             </a:pPr>
             <a:r>
-              <a:rPr sz="1000" b="0">
+              <a:rPr sz="900" b="0">
                 <a:solidFill>
                   <a:srgbClr val="3D4A54"/>
                 </a:solidFill>
                 <a:latin typeface="Arial"/>
               </a:rPr>
-              <a:t>Flyway · interop state</a:t>
+              <a:t>Municipal · Fire · MPCB</a:t>
             </a:r>
           </a:p>
         </p:txBody>
@@ -7400,8 +7400,8 @@
         </p:nvSpPr>
         <p:spPr>
           <a:xfrm>
-            <a:off x="4251960" y="1353312"/>
-            <a:ext cx="1783080" cy="713232"/>
+            <a:off x="8028432" y="1261872"/>
+            <a:ext cx="3657600" cy="530352"/>
           </a:xfrm>
           <a:prstGeom prst="roundRect">
             <a:avLst>
@@ -7447,8 +7447,8 @@
         </p:nvSpPr>
         <p:spPr>
           <a:xfrm>
-            <a:off x="4325112" y="1426464"/>
-            <a:ext cx="1673352" cy="347472"/>
+            <a:off x="8083296" y="1307592"/>
+            <a:ext cx="3566160" cy="256032"/>
           </a:xfrm>
           <a:prstGeom prst="rect">
             <a:avLst/>
@@ -7471,7 +7471,7 @@
                 </a:solidFill>
                 <a:latin typeface="Arial"/>
               </a:rPr>
-              <a:t>REST SOAP SFTP JDBC</a:t>
+              <a:t>Farmer subsidy</a:t>
             </a:r>
           </a:p>
         </p:txBody>
@@ -7484,8 +7484,8 @@
         </p:nvSpPr>
         <p:spPr>
           <a:xfrm>
-            <a:off x="4325112" y="1737360"/>
-            <a:ext cx="1673352" cy="256032"/>
+            <a:off x="8083296" y="1517904"/>
+            <a:ext cx="3566160" cy="256032"/>
           </a:xfrm>
           <a:prstGeom prst="rect">
             <a:avLst/>
@@ -7502,13 +7502,13 @@
               </a:spcAft>
             </a:pPr>
             <a:r>
-              <a:rPr sz="1000" b="0">
+              <a:rPr sz="900" b="0">
                 <a:solidFill>
                   <a:srgbClr val="3D4A54"/>
                 </a:solidFill>
                 <a:latin typeface="Arial"/>
               </a:rPr>
-              <a:t>protocol adapters</a:t>
+              <a:t>Land · Agri · DBT</a:t>
             </a:r>
           </a:p>
         </p:txBody>
@@ -7521,8 +7521,8 @@
         </p:nvSpPr>
         <p:spPr>
           <a:xfrm>
-            <a:off x="6172200" y="1353312"/>
-            <a:ext cx="1783080" cy="713232"/>
+            <a:off x="347472" y="1901952"/>
+            <a:ext cx="11475720" cy="2852928"/>
           </a:xfrm>
           <a:prstGeom prst="roundRect">
             <a:avLst>
@@ -7562,101 +7562,23 @@
       </p:sp>
       <p:sp>
         <p:nvSpPr>
-          <p:cNvPr id="17422" name="TextBox 17421"/>
-          <p:cNvSpPr txBox="1"/>
+          <p:cNvPr id="17422" name="Rectangle 17421"/>
+          <p:cNvSpPr/>
           <p:nvPr/>
         </p:nvSpPr>
         <p:spPr>
           <a:xfrm>
-            <a:off x="6245352" y="1426464"/>
-            <a:ext cx="1673352" cy="347472"/>
+            <a:off x="347472" y="1901952"/>
+            <a:ext cx="11475720" cy="347472"/>
           </a:xfrm>
           <a:prstGeom prst="rect">
             <a:avLst/>
           </a:prstGeom>
-          <a:noFill/>
-        </p:spPr>
-        <p:txBody>
-          <a:bodyPr wrap="square" anchor="t"/>
-          <a:lstStyle/>
-          <a:p>
-            <a:pPr algn="ctr">
-              <a:spcAft>
-                <a:spcPts val="400"/>
-              </a:spcAft>
-            </a:pPr>
-            <a:r>
-              <a:rPr sz="1100" b="1">
-                <a:solidFill>
-                  <a:srgbClr val="0B2E4A"/>
-                </a:solidFill>
-                <a:latin typeface="Arial"/>
-              </a:rPr>
-              <a:t>BPMN 2.0</a:t>
-            </a:r>
-          </a:p>
-        </p:txBody>
-      </p:sp>
-      <p:sp>
-        <p:nvSpPr>
-          <p:cNvPr id="17423" name="TextBox 17422"/>
-          <p:cNvSpPr txBox="1"/>
-          <p:nvPr/>
-        </p:nvSpPr>
-        <p:spPr>
-          <a:xfrm>
-            <a:off x="6245352" y="1737360"/>
-            <a:ext cx="1673352" cy="256032"/>
-          </a:xfrm>
-          <a:prstGeom prst="rect">
-            <a:avLst/>
-          </a:prstGeom>
-          <a:noFill/>
-        </p:spPr>
-        <p:txBody>
-          <a:bodyPr wrap="square" anchor="t"/>
-          <a:lstStyle/>
-          <a:p>
-            <a:pPr algn="ctr">
-              <a:spcAft>
-                <a:spcPts val="400"/>
-              </a:spcAft>
-            </a:pPr>
-            <a:r>
-              <a:rPr sz="1000" b="0">
-                <a:solidFill>
-                  <a:srgbClr val="3D4A54"/>
-                </a:solidFill>
-                <a:latin typeface="Arial"/>
-              </a:rPr>
-              <a:t>Flowable behind a port</a:t>
-            </a:r>
-          </a:p>
-        </p:txBody>
-      </p:sp>
-      <p:sp>
-        <p:nvSpPr>
-          <p:cNvPr id="17424" name="Rounded Rectangle 17423"/>
-          <p:cNvSpPr/>
-          <p:nvPr/>
-        </p:nvSpPr>
-        <p:spPr>
-          <a:xfrm>
-            <a:off x="8092440" y="1353312"/>
-            <a:ext cx="1783080" cy="713232"/>
-          </a:xfrm>
-          <a:prstGeom prst="roundRect">
-            <a:avLst>
-              <a:gd name="adj" fmla="val 8000"/>
-            </a:avLst>
-          </a:prstGeom>
           <a:solidFill>
-            <a:srgbClr val="F7F4EE"/>
+            <a:srgbClr val="0B2E4A"/>
           </a:solidFill>
-          <a:ln w="12700">
-            <a:solidFill>
-              <a:srgbClr val="D4CBB8"/>
-            </a:solidFill>
+          <a:ln>
+            <a:noFill/>
           </a:ln>
         </p:spPr>
         <p:style>
@@ -7683,14 +7605,14 @@
       </p:sp>
       <p:sp>
         <p:nvSpPr>
-          <p:cNvPr id="17425" name="TextBox 17424"/>
+          <p:cNvPr id="17423" name="TextBox 17422"/>
           <p:cNvSpPr txBox="1"/>
           <p:nvPr/>
         </p:nvSpPr>
         <p:spPr>
           <a:xfrm>
-            <a:off x="8165592" y="1426464"/>
-            <a:ext cx="1673352" cy="347472"/>
+            <a:off x="457200" y="1938528"/>
+            <a:ext cx="11247120" cy="292608"/>
           </a:xfrm>
           <a:prstGeom prst="rect">
             <a:avLst/>
@@ -7707,64 +7629,27 @@
               </a:spcAft>
             </a:pPr>
             <a:r>
-              <a:rPr sz="1100" b="1">
-                <a:solidFill>
-                  <a:srgbClr val="0B2E4A"/>
+              <a:rPr sz="1200" b="1">
+                <a:solidFill>
+                  <a:srgbClr val="FFFFFF"/>
                 </a:solidFill>
                 <a:latin typeface="Arial"/>
               </a:rPr>
-              <a:t>Keycloak</a:t>
-            </a:r>
-          </a:p>
-        </p:txBody>
-      </p:sp>
-      <p:sp>
-        <p:nvSpPr>
-          <p:cNvPr id="17426" name="TextBox 17425"/>
-          <p:cNvSpPr txBox="1"/>
-          <p:nvPr/>
-        </p:nvSpPr>
-        <p:spPr>
-          <a:xfrm>
-            <a:off x="8165592" y="1737360"/>
-            <a:ext cx="1673352" cy="256032"/>
-          </a:xfrm>
-          <a:prstGeom prst="rect">
-            <a:avLst/>
-          </a:prstGeom>
-          <a:noFill/>
-        </p:spPr>
-        <p:txBody>
-          <a:bodyPr wrap="square" anchor="t"/>
-          <a:lstStyle/>
-          <a:p>
-            <a:pPr algn="ctr">
-              <a:spcAft>
-                <a:spcPts val="400"/>
-              </a:spcAft>
-            </a:pPr>
-            <a:r>
-              <a:rPr sz="1000" b="0">
-                <a:solidFill>
-                  <a:srgbClr val="3D4A54"/>
-                </a:solidFill>
-                <a:latin typeface="Arial"/>
-              </a:rPr>
-              <a:t>OIDC / IdP brokering</a:t>
-            </a:r>
-          </a:p>
-        </p:txBody>
-      </p:sp>
-      <p:sp>
-        <p:nvSpPr>
-          <p:cNvPr id="17427" name="Rounded Rectangle 17426"/>
+              <a:t>SAMANVAY CORE  —  one Spring Boot deployable  ·  modules enforced at build (Modulith + ArchUnit)  ·  payload never persisted</a:t>
+            </a:r>
+          </a:p>
+        </p:txBody>
+      </p:sp>
+      <p:sp>
+        <p:nvSpPr>
+          <p:cNvPr id="17424" name="Rounded Rectangle 17423"/>
           <p:cNvSpPr/>
           <p:nvPr/>
         </p:nvSpPr>
         <p:spPr>
           <a:xfrm>
-            <a:off x="10012680" y="1353312"/>
-            <a:ext cx="1783080" cy="713232"/>
+            <a:off x="475488" y="2340864"/>
+            <a:ext cx="5074920" cy="1572768"/>
           </a:xfrm>
           <a:prstGeom prst="roundRect">
             <a:avLst>
@@ -7772,12 +7657,10 @@
             </a:avLst>
           </a:prstGeom>
           <a:solidFill>
-            <a:srgbClr val="F7F4EE"/>
+            <a:srgbClr val="0B2E4A"/>
           </a:solidFill>
-          <a:ln w="12700">
-            <a:solidFill>
-              <a:srgbClr val="D4CBB8"/>
-            </a:solidFill>
+          <a:ln>
+            <a:noFill/>
           </a:ln>
         </p:spPr>
         <p:style>
@@ -7804,14 +7687,14 @@
       </p:sp>
       <p:sp>
         <p:nvSpPr>
-          <p:cNvPr id="17428" name="TextBox 17427"/>
+          <p:cNvPr id="17425" name="TextBox 17424"/>
           <p:cNvSpPr txBox="1"/>
           <p:nvPr/>
         </p:nvSpPr>
         <p:spPr>
           <a:xfrm>
-            <a:off x="10085832" y="1426464"/>
-            <a:ext cx="1673352" cy="347472"/>
+            <a:off x="585216" y="2395728"/>
+            <a:ext cx="4846320" cy="256032"/>
           </a:xfrm>
           <a:prstGeom prst="rect">
             <a:avLst/>
@@ -7822,33 +7705,33 @@
           <a:bodyPr wrap="square" anchor="t"/>
           <a:lstStyle/>
           <a:p>
-            <a:pPr algn="ctr">
+            <a:pPr algn="l">
               <a:spcAft>
                 <a:spcPts val="400"/>
               </a:spcAft>
             </a:pPr>
             <a:r>
-              <a:rPr sz="1100" b="1">
-                <a:solidFill>
-                  <a:srgbClr val="0B2E4A"/>
+              <a:rPr sz="1200" b="1">
+                <a:solidFill>
+                  <a:srgbClr val="FFFFFF"/>
                 </a:solidFill>
                 <a:latin typeface="Arial"/>
               </a:rPr>
-              <a:t>Resilience4j</a:t>
-            </a:r>
-          </a:p>
-        </p:txBody>
-      </p:sp>
-      <p:sp>
-        <p:nvSpPr>
-          <p:cNvPr id="17429" name="TextBox 17428"/>
+              <a:t>CONTROL PLANE  —  decides</a:t>
+            </a:r>
+          </a:p>
+        </p:txBody>
+      </p:sp>
+      <p:sp>
+        <p:nvSpPr>
+          <p:cNvPr id="17426" name="TextBox 17425"/>
           <p:cNvSpPr txBox="1"/>
           <p:nvPr/>
         </p:nvSpPr>
         <p:spPr>
           <a:xfrm>
-            <a:off x="10085832" y="1737360"/>
-            <a:ext cx="1673352" cy="256032"/>
+            <a:off x="585216" y="2651760"/>
+            <a:ext cx="4846320" cy="1170432"/>
           </a:xfrm>
           <a:prstGeom prst="rect">
             <a:avLst/>
@@ -7859,70 +7742,81 @@
           <a:bodyPr wrap="square" anchor="t"/>
           <a:lstStyle/>
           <a:p>
-            <a:pPr algn="ctr">
-              <a:spcAft>
-                <a:spcPts val="400"/>
-              </a:spcAft>
-            </a:pPr>
-            <a:r>
-              <a:rPr sz="1000" b="0">
-                <a:solidFill>
-                  <a:srgbClr val="3D4A54"/>
-                </a:solidFill>
-                <a:latin typeface="Arial"/>
-              </a:rPr>
-              <a:t>timeout · circuit</a:t>
-            </a:r>
-          </a:p>
-        </p:txBody>
-      </p:sp>
-      <p:sp>
-        <p:nvSpPr>
-          <p:cNvPr id="17430" name="TextBox 17429"/>
-          <p:cNvSpPr txBox="1"/>
-          <p:nvPr/>
-        </p:nvSpPr>
-        <p:spPr>
-          <a:xfrm>
-            <a:off x="411480" y="2176272"/>
-            <a:ext cx="11338560" cy="256032"/>
-          </a:xfrm>
-          <a:prstGeom prst="rect">
-            <a:avLst/>
-          </a:prstGeom>
-          <a:noFill/>
-        </p:spPr>
-        <p:txBody>
-          <a:bodyPr wrap="square" anchor="t"/>
-          <a:lstStyle/>
-          <a:p>
             <a:pPr algn="l">
               <a:spcAft>
                 <a:spcPts val="400"/>
               </a:spcAft>
             </a:pPr>
             <a:r>
-              <a:rPr sz="1300" b="1">
-                <a:solidFill>
-                  <a:srgbClr val="C4561A"/>
+              <a:rPr sz="1100" b="0">
+                <a:solidFill>
+                  <a:srgbClr val="FFFFFF"/>
                 </a:solidFill>
                 <a:latin typeface="Arial"/>
               </a:rPr>
-              <a:t>Methodology — departments issue; Samanvay orchestrates the pull</a:t>
-            </a:r>
-          </a:p>
-        </p:txBody>
-      </p:sp>
-      <p:sp>
-        <p:nvSpPr>
-          <p:cNvPr id="17431" name="Rounded Rectangle 17430"/>
+              <a:t>identity   citizen links  ·  no auto-merge</a:t>
+            </a:r>
+          </a:p>
+          <a:p>
+            <a:pPr algn="l">
+              <a:spcAft>
+                <a:spcPts val="400"/>
+              </a:spcAft>
+            </a:pPr>
+            <a:r>
+              <a:rPr sz="1100" b="0">
+                <a:solidFill>
+                  <a:srgbClr val="FFFFFF"/>
+                </a:solidFill>
+                <a:latin typeface="Arial"/>
+              </a:rPr>
+              <a:t>consent    purpose  ·  revoke  ·  issues the grant</a:t>
+            </a:r>
+          </a:p>
+          <a:p>
+            <a:pPr algn="l">
+              <a:spcAft>
+                <a:spcPts val="400"/>
+              </a:spcAft>
+            </a:pPr>
+            <a:r>
+              <a:rPr sz="1100" b="0">
+                <a:solidFill>
+                  <a:srgbClr val="FFFFFF"/>
+                </a:solidFill>
+                <a:latin typeface="Arial"/>
+              </a:rPr>
+              <a:t>catalog    departments  ·  schemas  ·  journeys</a:t>
+            </a:r>
+          </a:p>
+          <a:p>
+            <a:pPr algn="l">
+              <a:spcAft>
+                <a:spcPts val="400"/>
+              </a:spcAft>
+            </a:pPr>
+            <a:r>
+              <a:rPr sz="1100" b="0">
+                <a:solidFill>
+                  <a:srgbClr val="FFFFFF"/>
+                </a:solidFill>
+                <a:latin typeface="Arial"/>
+              </a:rPr>
+              <a:t>registry   pointers only  —  what exists where</a:t>
+            </a:r>
+          </a:p>
+        </p:txBody>
+      </p:sp>
+      <p:sp>
+        <p:nvSpPr>
+          <p:cNvPr id="17427" name="Rounded Rectangle 17426"/>
           <p:cNvSpPr/>
           <p:nvPr/>
         </p:nvSpPr>
         <p:spPr>
           <a:xfrm>
-            <a:off x="365760" y="2468880"/>
-            <a:ext cx="2606040" cy="960120"/>
+            <a:off x="6601968" y="2340864"/>
+            <a:ext cx="5074920" cy="1572768"/>
           </a:xfrm>
           <a:prstGeom prst="roundRect">
             <a:avLst>
@@ -7960,14 +7854,14 @@
       </p:sp>
       <p:sp>
         <p:nvSpPr>
-          <p:cNvPr id="17432" name="TextBox 17431"/>
+          <p:cNvPr id="17428" name="TextBox 17427"/>
           <p:cNvSpPr txBox="1"/>
           <p:nvPr/>
         </p:nvSpPr>
         <p:spPr>
           <a:xfrm>
-            <a:off x="457200" y="2578608"/>
-            <a:ext cx="2423160" cy="329184"/>
+            <a:off x="6711696" y="2395728"/>
+            <a:ext cx="4846320" cy="256032"/>
           </a:xfrm>
           <a:prstGeom prst="rect">
             <a:avLst/>
@@ -7978,33 +7872,33 @@
           <a:bodyPr wrap="square" anchor="t"/>
           <a:lstStyle/>
           <a:p>
-            <a:pPr algn="ctr">
+            <a:pPr algn="l">
               <a:spcAft>
                 <a:spcPts val="400"/>
               </a:spcAft>
             </a:pPr>
             <a:r>
-              <a:rPr sz="1300" b="1">
+              <a:rPr sz="1200" b="1">
                 <a:solidFill>
                   <a:srgbClr val="FFFFFF"/>
                 </a:solidFill>
                 <a:latin typeface="Arial"/>
               </a:rPr>
-              <a:t>Citizen portals</a:t>
-            </a:r>
-          </a:p>
-        </p:txBody>
-      </p:sp>
-      <p:sp>
-        <p:nvSpPr>
-          <p:cNvPr id="17433" name="TextBox 17432"/>
+              <a:t>DATA PLANE  —  moves</a:t>
+            </a:r>
+          </a:p>
+        </p:txBody>
+      </p:sp>
+      <p:sp>
+        <p:nvSpPr>
+          <p:cNvPr id="17429" name="TextBox 17428"/>
           <p:cNvSpPr txBox="1"/>
           <p:nvPr/>
         </p:nvSpPr>
         <p:spPr>
           <a:xfrm>
-            <a:off x="457200" y="2926080"/>
-            <a:ext cx="2423160" cy="438912"/>
+            <a:off x="6711696" y="2651760"/>
+            <a:ext cx="4846320" cy="1170432"/>
           </a:xfrm>
           <a:prstGeom prst="rect">
             <a:avLst/>
@@ -8015,33 +7909,81 @@
           <a:bodyPr wrap="square" anchor="t"/>
           <a:lstStyle/>
           <a:p>
-            <a:pPr algn="ctr">
+            <a:pPr algn="l">
               <a:spcAft>
                 <a:spcPts val="400"/>
               </a:spcAft>
             </a:pPr>
             <a:r>
-              <a:rPr sz="1000" b="0">
+              <a:rPr sz="1100" b="0">
                 <a:solidFill>
                   <a:srgbClr val="FFFFFF"/>
                 </a:solidFill>
                 <a:latin typeface="Arial"/>
               </a:rPr>
-              <a:t>Scholarship / Licence / Farmer</a:t>
-            </a:r>
-          </a:p>
-        </p:txBody>
-      </p:sp>
-      <p:sp>
-        <p:nvSpPr>
-          <p:cNvPr id="17434" name="Right Arrow 17433"/>
+              <a:t>orchestration   BPMN journey  ·  retry / degrade</a:t>
+            </a:r>
+          </a:p>
+          <a:p>
+            <a:pPr algn="l">
+              <a:spcAft>
+                <a:spcPts val="400"/>
+              </a:spcAft>
+            </a:pPr>
+            <a:r>
+              <a:rPr sz="1100" b="0">
+                <a:solidFill>
+                  <a:srgbClr val="FFFFFF"/>
+                </a:solidFill>
+                <a:latin typeface="Arial"/>
+              </a:rPr>
+              <a:t>connector       adapters + mapping DSL</a:t>
+            </a:r>
+          </a:p>
+          <a:p>
+            <a:pPr algn="l">
+              <a:spcAft>
+                <a:spcPts val="400"/>
+              </a:spcAft>
+            </a:pPr>
+            <a:r>
+              <a:rPr sz="1100" b="0">
+                <a:solidFill>
+                  <a:srgbClr val="FFFFFF"/>
+                </a:solidFill>
+                <a:latin typeface="Arial"/>
+              </a:rPr>
+              <a:t>tracking        one reference number</a:t>
+            </a:r>
+          </a:p>
+          <a:p>
+            <a:pPr algn="l">
+              <a:spcAft>
+                <a:spcPts val="400"/>
+              </a:spcAft>
+            </a:pPr>
+            <a:r>
+              <a:rPr sz="1100" b="0">
+                <a:solidFill>
+                  <a:srgbClr val="FFFFFF"/>
+                </a:solidFill>
+                <a:latin typeface="Arial"/>
+              </a:rPr>
+              <a:t>notifications   events  ·  citizen / officer</a:t>
+            </a:r>
+          </a:p>
+        </p:txBody>
+      </p:sp>
+      <p:sp>
+        <p:nvSpPr>
+          <p:cNvPr id="17430" name="Right Arrow 17429"/>
           <p:cNvSpPr/>
           <p:nvPr/>
         </p:nvSpPr>
         <p:spPr>
           <a:xfrm>
-            <a:off x="3008376" y="2816352"/>
-            <a:ext cx="256032" cy="256032"/>
+            <a:off x="5632704" y="2907792"/>
+            <a:ext cx="877824" cy="384048"/>
           </a:xfrm>
           <a:prstGeom prst="rightArrow">
             <a:avLst/>
@@ -8077,14 +8019,67 @@
       </p:sp>
       <p:sp>
         <p:nvSpPr>
-          <p:cNvPr id="17435" name="Rounded Rectangle 17434"/>
+          <p:cNvPr id="17431" name="TextBox 17430"/>
+          <p:cNvSpPr txBox="1"/>
+          <p:nvPr/>
+        </p:nvSpPr>
+        <p:spPr>
+          <a:xfrm>
+            <a:off x="5596128" y="3310128"/>
+            <a:ext cx="960120" cy="384048"/>
+          </a:xfrm>
+          <a:prstGeom prst="rect">
+            <a:avLst/>
+          </a:prstGeom>
+          <a:noFill/>
+        </p:spPr>
+        <p:txBody>
+          <a:bodyPr wrap="square" anchor="t"/>
+          <a:lstStyle/>
+          <a:p>
+            <a:pPr algn="ctr">
+              <a:spcAft>
+                <a:spcPts val="400"/>
+              </a:spcAft>
+            </a:pPr>
+            <a:r>
+              <a:rPr sz="900" b="1">
+                <a:solidFill>
+                  <a:srgbClr val="C4561A"/>
+                </a:solidFill>
+                <a:latin typeface="Arial"/>
+              </a:rPr>
+              <a:t>60s grant</a:t>
+            </a:r>
+          </a:p>
+          <a:p>
+            <a:pPr algn="ctr">
+              <a:spcAft>
+                <a:spcPts val="400"/>
+              </a:spcAft>
+            </a:pPr>
+            <a:r>
+              <a:rPr sz="900" b="1">
+                <a:solidFill>
+                  <a:srgbClr val="C4561A"/>
+                </a:solidFill>
+                <a:latin typeface="Arial"/>
+              </a:rPr>
+              <a:t>single-use</a:t>
+            </a:r>
+          </a:p>
+        </p:txBody>
+      </p:sp>
+      <p:sp>
+        <p:nvSpPr>
+          <p:cNvPr id="17432" name="Rounded Rectangle 17431"/>
           <p:cNvSpPr/>
           <p:nvPr/>
         </p:nvSpPr>
         <p:spPr>
           <a:xfrm>
-            <a:off x="3291840" y="2468880"/>
-            <a:ext cx="2606040" cy="960120"/>
+            <a:off x="475488" y="4005072"/>
+            <a:ext cx="11201400" cy="621792"/>
           </a:xfrm>
           <a:prstGeom prst="roundRect">
             <a:avLst>
@@ -8092,10 +8087,12 @@
             </a:avLst>
           </a:prstGeom>
           <a:solidFill>
-            <a:srgbClr val="0B2E4A"/>
+            <a:srgbClr val="F3E6D8"/>
           </a:solidFill>
-          <a:ln>
-            <a:noFill/>
+          <a:ln w="12700">
+            <a:solidFill>
+              <a:srgbClr val="C4561A"/>
+            </a:solidFill>
           </a:ln>
         </p:spPr>
         <p:style>
@@ -8122,14 +8119,14 @@
       </p:sp>
       <p:sp>
         <p:nvSpPr>
-          <p:cNvPr id="17436" name="TextBox 17435"/>
+          <p:cNvPr id="17433" name="TextBox 17432"/>
           <p:cNvSpPr txBox="1"/>
           <p:nvPr/>
         </p:nvSpPr>
         <p:spPr>
           <a:xfrm>
-            <a:off x="3383280" y="2578608"/>
-            <a:ext cx="2423160" cy="329184"/>
+            <a:off x="585216" y="4059936"/>
+            <a:ext cx="10972800" cy="256032"/>
           </a:xfrm>
           <a:prstGeom prst="rect">
             <a:avLst/>
@@ -8140,33 +8137,33 @@
           <a:bodyPr wrap="square" anchor="t"/>
           <a:lstStyle/>
           <a:p>
-            <a:pPr algn="ctr">
+            <a:pPr algn="l">
               <a:spcAft>
                 <a:spcPts val="400"/>
               </a:spcAft>
             </a:pPr>
             <a:r>
-              <a:rPr sz="1300" b="1">
-                <a:solidFill>
-                  <a:srgbClr val="FFFFFF"/>
+              <a:rPr sz="1200" b="1">
+                <a:solidFill>
+                  <a:srgbClr val="C4561A"/>
                 </a:solidFill>
                 <a:latin typeface="Arial"/>
               </a:rPr>
-              <a:t>Samanvay control</a:t>
-            </a:r>
-          </a:p>
-        </p:txBody>
-      </p:sp>
-      <p:sp>
-        <p:nvSpPr>
-          <p:cNvPr id="17437" name="TextBox 17436"/>
+              <a:t>CROSS-CUTTING AUDIT  —  hash-chained ledger</a:t>
+            </a:r>
+          </a:p>
+        </p:txBody>
+      </p:sp>
+      <p:sp>
+        <p:nvSpPr>
+          <p:cNvPr id="17434" name="TextBox 17433"/>
           <p:cNvSpPr txBox="1"/>
           <p:nvPr/>
         </p:nvSpPr>
         <p:spPr>
           <a:xfrm>
-            <a:off x="3383280" y="2926080"/>
-            <a:ext cx="2423160" cy="438912"/>
+            <a:off x="585216" y="4297680"/>
+            <a:ext cx="10972800" cy="256032"/>
           </a:xfrm>
           <a:prstGeom prst="rect">
             <a:avLst/>
@@ -8177,42 +8174,83 @@
           <a:bodyPr wrap="square" anchor="t"/>
           <a:lstStyle/>
           <a:p>
-            <a:pPr algn="ctr">
+            <a:pPr algn="l">
               <a:spcAft>
                 <a:spcPts val="400"/>
               </a:spcAft>
             </a:pPr>
             <a:r>
-              <a:rPr sz="1000" b="0">
-                <a:solidFill>
-                  <a:srgbClr val="FFFFFF"/>
+              <a:rPr sz="1100" b="0">
+                <a:solidFill>
+                  <a:srgbClr val="1A1A1A"/>
                 </a:solidFill>
                 <a:latin typeface="Arial"/>
               </a:rPr>
-              <a:t>identity · consent · catalog · registry</a:t>
-            </a:r>
-          </a:p>
-        </p:txBody>
-      </p:sp>
-      <p:sp>
-        <p:nvSpPr>
-          <p:cNvPr id="17438" name="Right Arrow 17437"/>
+              <a:t>Every grant, fetch, retry, consent revoke. Tamper a row → chain verify fails. Live fetch with provenance; certificates stay at the issuer.</a:t>
+            </a:r>
+          </a:p>
+        </p:txBody>
+      </p:sp>
+      <p:sp>
+        <p:nvSpPr>
+          <p:cNvPr id="17435" name="TextBox 17434"/>
+          <p:cNvSpPr txBox="1"/>
+          <p:nvPr/>
+        </p:nvSpPr>
+        <p:spPr>
+          <a:xfrm>
+            <a:off x="347472" y="4828032"/>
+            <a:ext cx="11430000" cy="201168"/>
+          </a:xfrm>
+          <a:prstGeom prst="rect">
+            <a:avLst/>
+          </a:prstGeom>
+          <a:noFill/>
+        </p:spPr>
+        <p:txBody>
+          <a:bodyPr wrap="square" anchor="t"/>
+          <a:lstStyle/>
+          <a:p>
+            <a:pPr algn="l">
+              <a:spcAft>
+                <a:spcPts val="400"/>
+              </a:spcAft>
+            </a:pPr>
+            <a:r>
+              <a:rPr sz="1100" b="1">
+                <a:solidFill>
+                  <a:srgbClr val="C4561A"/>
+                </a:solidFill>
+                <a:latin typeface="Arial"/>
+              </a:rPr>
+              <a:t>Issuers stay systems of record  —  fetch on demand</a:t>
+            </a:r>
+          </a:p>
+        </p:txBody>
+      </p:sp>
+      <p:sp>
+        <p:nvSpPr>
+          <p:cNvPr id="17436" name="Rounded Rectangle 17435"/>
           <p:cNvSpPr/>
           <p:nvPr/>
         </p:nvSpPr>
         <p:spPr>
           <a:xfrm>
-            <a:off x="5934456" y="2816352"/>
-            <a:ext cx="256032" cy="256032"/>
-          </a:xfrm>
-          <a:prstGeom prst="rightArrow">
-            <a:avLst/>
+            <a:off x="347472" y="5029200"/>
+            <a:ext cx="1828800" cy="530352"/>
+          </a:xfrm>
+          <a:prstGeom prst="roundRect">
+            <a:avLst>
+              <a:gd name="adj" fmla="val 8000"/>
+            </a:avLst>
           </a:prstGeom>
           <a:solidFill>
-            <a:srgbClr val="C4561A"/>
+            <a:srgbClr val="F7F4EE"/>
           </a:solidFill>
-          <a:ln>
-            <a:noFill/>
+          <a:ln w="12700">
+            <a:solidFill>
+              <a:srgbClr val="D4CBB8"/>
+            </a:solidFill>
           </a:ln>
         </p:spPr>
         <p:style>
@@ -8239,14 +8277,88 @@
       </p:sp>
       <p:sp>
         <p:nvSpPr>
+          <p:cNvPr id="17437" name="TextBox 17436"/>
+          <p:cNvSpPr txBox="1"/>
+          <p:nvPr/>
+        </p:nvSpPr>
+        <p:spPr>
+          <a:xfrm>
+            <a:off x="402336" y="5074920"/>
+            <a:ext cx="1737360" cy="256032"/>
+          </a:xfrm>
+          <a:prstGeom prst="rect">
+            <a:avLst/>
+          </a:prstGeom>
+          <a:noFill/>
+        </p:spPr>
+        <p:txBody>
+          <a:bodyPr wrap="square" anchor="t"/>
+          <a:lstStyle/>
+          <a:p>
+            <a:pPr algn="ctr">
+              <a:spcAft>
+                <a:spcPts val="400"/>
+              </a:spcAft>
+            </a:pPr>
+            <a:r>
+              <a:rPr sz="1100" b="1">
+                <a:solidFill>
+                  <a:srgbClr val="0B2E4A"/>
+                </a:solidFill>
+                <a:latin typeface="Arial"/>
+              </a:rPr>
+              <a:t>Aaple Sarkar</a:t>
+            </a:r>
+          </a:p>
+        </p:txBody>
+      </p:sp>
+      <p:sp>
+        <p:nvSpPr>
+          <p:cNvPr id="17438" name="TextBox 17437"/>
+          <p:cNvSpPr txBox="1"/>
+          <p:nvPr/>
+        </p:nvSpPr>
+        <p:spPr>
+          <a:xfrm>
+            <a:off x="402336" y="5285232"/>
+            <a:ext cx="1737360" cy="256032"/>
+          </a:xfrm>
+          <a:prstGeom prst="rect">
+            <a:avLst/>
+          </a:prstGeom>
+          <a:noFill/>
+        </p:spPr>
+        <p:txBody>
+          <a:bodyPr wrap="square" anchor="t"/>
+          <a:lstStyle/>
+          <a:p>
+            <a:pPr algn="ctr">
+              <a:spcAft>
+                <a:spcPts val="400"/>
+              </a:spcAft>
+            </a:pPr>
+            <a:r>
+              <a:rPr sz="900" b="0">
+                <a:solidFill>
+                  <a:srgbClr val="3D4A54"/>
+                </a:solidFill>
+                <a:latin typeface="Arial"/>
+              </a:rPr>
+              <a:t>SOAP / REST</a:t>
+            </a:r>
+          </a:p>
+        </p:txBody>
+      </p:sp>
+      <p:sp>
+        <p:nvSpPr>
           <p:cNvPr id="17439" name="Rounded Rectangle 17438"/>
           <p:cNvSpPr/>
           <p:nvPr/>
         </p:nvSpPr>
         <p:spPr>
           <a:xfrm>
-            <a:off x="6217920" y="2468880"/>
-            <a:ext cx="2606040" cy="960120"/>
+            <a:off x="2267712" y="5029200"/>
+            <a:ext cx="1828800" cy="530352"/>
           </a:xfrm>
           <a:prstGeom prst="roundRect">
             <a:avLst>
@@ -8254,10 +8366,12 @@
             </a:avLst>
           </a:prstGeom>
           <a:solidFill>
-            <a:srgbClr val="0B2E4A"/>
+            <a:srgbClr val="F7F4EE"/>
           </a:solidFill>
-          <a:ln>
-            <a:noFill/>
+          <a:ln w="12700">
+            <a:solidFill>
+              <a:srgbClr val="D4CBB8"/>
+            </a:solidFill>
           </a:ln>
         </p:spPr>
         <p:style>
@@ -8290,8 +8404,8 @@
         </p:nvSpPr>
         <p:spPr>
           <a:xfrm>
-            <a:off x="6309360" y="2578608"/>
-            <a:ext cx="2423160" cy="329184"/>
+            <a:off x="2322576" y="5074920"/>
+            <a:ext cx="1737360" cy="256032"/>
           </a:xfrm>
           <a:prstGeom prst="rect">
             <a:avLst/>
@@ -8308,13 +8422,13 @@
               </a:spcAft>
             </a:pPr>
             <a:r>
-              <a:rPr sz="1300" b="1">
-                <a:solidFill>
-                  <a:srgbClr val="FFFFFF"/>
+              <a:rPr sz="1100" b="1">
+                <a:solidFill>
+                  <a:srgbClr val="0B2E4A"/>
                 </a:solidFill>
                 <a:latin typeface="Arial"/>
               </a:rPr>
-              <a:t>Samanvay data</a:t>
+              <a:t>Mahabhulekh</a:t>
             </a:r>
           </a:p>
         </p:txBody>
@@ -8327,8 +8441,8 @@
         </p:nvSpPr>
         <p:spPr>
           <a:xfrm>
-            <a:off x="6309360" y="2926080"/>
-            <a:ext cx="2423160" cy="438912"/>
+            <a:off x="2322576" y="5285232"/>
+            <a:ext cx="1737360" cy="256032"/>
           </a:xfrm>
           <a:prstGeom prst="rect">
             <a:avLst/>
@@ -8345,36 +8459,40 @@
               </a:spcAft>
             </a:pPr>
             <a:r>
-              <a:rPr sz="1000" b="0">
-                <a:solidFill>
-                  <a:srgbClr val="FFFFFF"/>
+              <a:rPr sz="900" b="0">
+                <a:solidFill>
+                  <a:srgbClr val="3D4A54"/>
                 </a:solidFill>
                 <a:latin typeface="Arial"/>
               </a:rPr>
-              <a:t>connector · orchestration · tracking</a:t>
-            </a:r>
-          </a:p>
-        </p:txBody>
-      </p:sp>
-      <p:sp>
-        <p:nvSpPr>
-          <p:cNvPr id="17442" name="Right Arrow 17441"/>
+              <a:t>7/12 land</a:t>
+            </a:r>
+          </a:p>
+        </p:txBody>
+      </p:sp>
+      <p:sp>
+        <p:nvSpPr>
+          <p:cNvPr id="17442" name="Rounded Rectangle 17441"/>
           <p:cNvSpPr/>
           <p:nvPr/>
         </p:nvSpPr>
         <p:spPr>
           <a:xfrm>
-            <a:off x="8860536" y="2816352"/>
-            <a:ext cx="256032" cy="256032"/>
-          </a:xfrm>
-          <a:prstGeom prst="rightArrow">
-            <a:avLst/>
+            <a:off x="4187952" y="5029200"/>
+            <a:ext cx="1828800" cy="530352"/>
+          </a:xfrm>
+          <a:prstGeom prst="roundRect">
+            <a:avLst>
+              <a:gd name="adj" fmla="val 8000"/>
+            </a:avLst>
           </a:prstGeom>
           <a:solidFill>
-            <a:srgbClr val="C4561A"/>
+            <a:srgbClr val="F7F4EE"/>
           </a:solidFill>
-          <a:ln>
-            <a:noFill/>
+          <a:ln w="12700">
+            <a:solidFill>
+              <a:srgbClr val="D4CBB8"/>
+            </a:solidFill>
           </a:ln>
         </p:spPr>
         <p:style>
@@ -8401,14 +8519,88 @@
       </p:sp>
       <p:sp>
         <p:nvSpPr>
-          <p:cNvPr id="17443" name="Rounded Rectangle 17442"/>
+          <p:cNvPr id="17443" name="TextBox 17442"/>
+          <p:cNvSpPr txBox="1"/>
+          <p:nvPr/>
+        </p:nvSpPr>
+        <p:spPr>
+          <a:xfrm>
+            <a:off x="4242816" y="5074920"/>
+            <a:ext cx="1737360" cy="256032"/>
+          </a:xfrm>
+          <a:prstGeom prst="rect">
+            <a:avLst/>
+          </a:prstGeom>
+          <a:noFill/>
+        </p:spPr>
+        <p:txBody>
+          <a:bodyPr wrap="square" anchor="t"/>
+          <a:lstStyle/>
+          <a:p>
+            <a:pPr algn="ctr">
+              <a:spcAft>
+                <a:spcPts val="400"/>
+              </a:spcAft>
+            </a:pPr>
+            <a:r>
+              <a:rPr sz="1100" b="1">
+                <a:solidFill>
+                  <a:srgbClr val="0B2E4A"/>
+                </a:solidFill>
+                <a:latin typeface="Arial"/>
+              </a:rPr>
+              <a:t>Fire e-approval</a:t>
+            </a:r>
+          </a:p>
+        </p:txBody>
+      </p:sp>
+      <p:sp>
+        <p:nvSpPr>
+          <p:cNvPr id="17444" name="TextBox 17443"/>
+          <p:cNvSpPr txBox="1"/>
+          <p:nvPr/>
+        </p:nvSpPr>
+        <p:spPr>
+          <a:xfrm>
+            <a:off x="4242816" y="5285232"/>
+            <a:ext cx="1737360" cy="256032"/>
+          </a:xfrm>
+          <a:prstGeom prst="rect">
+            <a:avLst/>
+          </a:prstGeom>
+          <a:noFill/>
+        </p:spPr>
+        <p:txBody>
+          <a:bodyPr wrap="square" anchor="t"/>
+          <a:lstStyle/>
+          <a:p>
+            <a:pPr algn="ctr">
+              <a:spcAft>
+                <a:spcPts val="400"/>
+              </a:spcAft>
+            </a:pPr>
+            <a:r>
+              <a:rPr sz="900" b="0">
+                <a:solidFill>
+                  <a:srgbClr val="3D4A54"/>
+                </a:solidFill>
+                <a:latin typeface="Arial"/>
+              </a:rPr>
+              <a:t>NOC API</a:t>
+            </a:r>
+          </a:p>
+        </p:txBody>
+      </p:sp>
+      <p:sp>
+        <p:nvSpPr>
+          <p:cNvPr id="17445" name="Rounded Rectangle 17444"/>
           <p:cNvSpPr/>
           <p:nvPr/>
         </p:nvSpPr>
         <p:spPr>
           <a:xfrm>
-            <a:off x="9144000" y="2468880"/>
-            <a:ext cx="2606040" cy="960120"/>
+            <a:off x="6108192" y="5029200"/>
+            <a:ext cx="1828800" cy="530352"/>
           </a:xfrm>
           <a:prstGeom prst="roundRect">
             <a:avLst>
@@ -8416,10 +8608,12 @@
             </a:avLst>
           </a:prstGeom>
           <a:solidFill>
-            <a:srgbClr val="0D6E6E"/>
+            <a:srgbClr val="F7F4EE"/>
           </a:solidFill>
-          <a:ln>
-            <a:noFill/>
+          <a:ln w="12700">
+            <a:solidFill>
+              <a:srgbClr val="D4CBB8"/>
+            </a:solidFill>
           </a:ln>
         </p:spPr>
         <p:style>
@@ -8446,14 +8640,14 @@
       </p:sp>
       <p:sp>
         <p:nvSpPr>
-          <p:cNvPr id="17444" name="TextBox 17443"/>
+          <p:cNvPr id="17446" name="TextBox 17445"/>
           <p:cNvSpPr txBox="1"/>
           <p:nvPr/>
         </p:nvSpPr>
         <p:spPr>
           <a:xfrm>
-            <a:off x="9235440" y="2578608"/>
-            <a:ext cx="2423160" cy="329184"/>
+            <a:off x="6163056" y="5074920"/>
+            <a:ext cx="1737360" cy="256032"/>
           </a:xfrm>
           <a:prstGeom prst="rect">
             <a:avLst/>
@@ -8470,27 +8664,27 @@
               </a:spcAft>
             </a:pPr>
             <a:r>
-              <a:rPr sz="1300" b="1">
-                <a:solidFill>
-                  <a:srgbClr val="FFFFFF"/>
+              <a:rPr sz="1100" b="1">
+                <a:solidFill>
+                  <a:srgbClr val="0B2E4A"/>
                 </a:solidFill>
                 <a:latin typeface="Arial"/>
               </a:rPr>
-              <a:t>Issuers (SoR)</a:t>
-            </a:r>
-          </a:p>
-        </p:txBody>
-      </p:sp>
-      <p:sp>
-        <p:nvSpPr>
-          <p:cNvPr id="17445" name="TextBox 17444"/>
+              <a:t>MPCB / MAITRI</a:t>
+            </a:r>
+          </a:p>
+        </p:txBody>
+      </p:sp>
+      <p:sp>
+        <p:nvSpPr>
+          <p:cNvPr id="17447" name="TextBox 17446"/>
           <p:cNvSpPr txBox="1"/>
           <p:nvPr/>
         </p:nvSpPr>
         <p:spPr>
           <a:xfrm>
-            <a:off x="9235440" y="2926080"/>
-            <a:ext cx="2423160" cy="438912"/>
+            <a:off x="6163056" y="5285232"/>
+            <a:ext cx="1737360" cy="256032"/>
           </a:xfrm>
           <a:prstGeom prst="rect">
             <a:avLst/>
@@ -8507,27 +8701,74 @@
               </a:spcAft>
             </a:pPr>
             <a:r>
-              <a:rPr sz="1000" b="0">
-                <a:solidFill>
-                  <a:srgbClr val="FFFFFF"/>
+              <a:rPr sz="900" b="0">
+                <a:solidFill>
+                  <a:srgbClr val="3D4A54"/>
                 </a:solidFill>
                 <a:latin typeface="Arial"/>
               </a:rPr>
-              <a:t>Aaple Sarkar · Bhulekh · Fire · MPCB · MahaDBT</a:t>
-            </a:r>
-          </a:p>
-        </p:txBody>
-      </p:sp>
-      <p:sp>
-        <p:nvSpPr>
-          <p:cNvPr id="17446" name="TextBox 17445"/>
+              <a:t>JDBC / REST</a:t>
+            </a:r>
+          </a:p>
+        </p:txBody>
+      </p:sp>
+      <p:sp>
+        <p:nvSpPr>
+          <p:cNvPr id="17448" name="Rounded Rectangle 17447"/>
+          <p:cNvSpPr/>
+          <p:nvPr/>
+        </p:nvSpPr>
+        <p:spPr>
+          <a:xfrm>
+            <a:off x="8028432" y="5029200"/>
+            <a:ext cx="1828800" cy="530352"/>
+          </a:xfrm>
+          <a:prstGeom prst="roundRect">
+            <a:avLst>
+              <a:gd name="adj" fmla="val 8000"/>
+            </a:avLst>
+          </a:prstGeom>
+          <a:solidFill>
+            <a:srgbClr val="F7F4EE"/>
+          </a:solidFill>
+          <a:ln w="12700">
+            <a:solidFill>
+              <a:srgbClr val="D4CBB8"/>
+            </a:solidFill>
+          </a:ln>
+        </p:spPr>
+        <p:style>
+          <a:lnRef idx="1">
+            <a:schemeClr val="accent1"/>
+          </a:lnRef>
+          <a:fillRef idx="3">
+            <a:schemeClr val="accent1"/>
+          </a:fillRef>
+          <a:effectRef idx="2">
+            <a:schemeClr val="accent1"/>
+          </a:effectRef>
+          <a:fontRef idx="minor">
+            <a:schemeClr val="lt1"/>
+          </a:fontRef>
+        </p:style>
+        <p:txBody>
+          <a:bodyPr rtlCol="0" anchor="ctr"/>
+          <a:lstStyle/>
+          <a:p>
+            <a:pPr algn="ctr"/>
+          </a:p>
+        </p:txBody>
+      </p:sp>
+      <p:sp>
+        <p:nvSpPr>
+          <p:cNvPr id="17449" name="TextBox 17448"/>
           <p:cNvSpPr txBox="1"/>
           <p:nvPr/>
         </p:nvSpPr>
         <p:spPr>
           <a:xfrm>
-            <a:off x="411480" y="3566160"/>
-            <a:ext cx="11338560" cy="2194560"/>
+            <a:off x="8083296" y="5074920"/>
+            <a:ext cx="1737360" cy="256032"/>
           </a:xfrm>
           <a:prstGeom prst="rect">
             <a:avLst/>
@@ -8538,67 +8779,214 @@
           <a:bodyPr wrap="square" anchor="t"/>
           <a:lstStyle/>
           <a:p>
+            <a:pPr algn="ctr">
+              <a:spcAft>
+                <a:spcPts val="400"/>
+              </a:spcAft>
+            </a:pPr>
+            <a:r>
+              <a:rPr sz="1100" b="1">
+                <a:solidFill>
+                  <a:srgbClr val="0B2E4A"/>
+                </a:solidFill>
+                <a:latin typeface="Arial"/>
+              </a:rPr>
+              <a:t>MahaDBT</a:t>
+            </a:r>
+          </a:p>
+        </p:txBody>
+      </p:sp>
+      <p:sp>
+        <p:nvSpPr>
+          <p:cNvPr id="17450" name="TextBox 17449"/>
+          <p:cNvSpPr txBox="1"/>
+          <p:nvPr/>
+        </p:nvSpPr>
+        <p:spPr>
+          <a:xfrm>
+            <a:off x="8083296" y="5285232"/>
+            <a:ext cx="1737360" cy="256032"/>
+          </a:xfrm>
+          <a:prstGeom prst="rect">
+            <a:avLst/>
+          </a:prstGeom>
+          <a:noFill/>
+        </p:spPr>
+        <p:txBody>
+          <a:bodyPr wrap="square" anchor="t"/>
+          <a:lstStyle/>
+          <a:p>
+            <a:pPr algn="ctr">
+              <a:spcAft>
+                <a:spcPts val="400"/>
+              </a:spcAft>
+            </a:pPr>
+            <a:r>
+              <a:rPr sz="900" b="0">
+                <a:solidFill>
+                  <a:srgbClr val="3D4A54"/>
+                </a:solidFill>
+                <a:latin typeface="Arial"/>
+              </a:rPr>
+              <a:t>REST + OAuth</a:t>
+            </a:r>
+          </a:p>
+        </p:txBody>
+      </p:sp>
+      <p:sp>
+        <p:nvSpPr>
+          <p:cNvPr id="17451" name="Rounded Rectangle 17450"/>
+          <p:cNvSpPr/>
+          <p:nvPr/>
+        </p:nvSpPr>
+        <p:spPr>
+          <a:xfrm>
+            <a:off x="9948672" y="5029200"/>
+            <a:ext cx="1828800" cy="530352"/>
+          </a:xfrm>
+          <a:prstGeom prst="roundRect">
+            <a:avLst>
+              <a:gd name="adj" fmla="val 8000"/>
+            </a:avLst>
+          </a:prstGeom>
+          <a:solidFill>
+            <a:srgbClr val="F7F4EE"/>
+          </a:solidFill>
+          <a:ln w="12700">
+            <a:solidFill>
+              <a:srgbClr val="D4CBB8"/>
+            </a:solidFill>
+          </a:ln>
+        </p:spPr>
+        <p:style>
+          <a:lnRef idx="1">
+            <a:schemeClr val="accent1"/>
+          </a:lnRef>
+          <a:fillRef idx="3">
+            <a:schemeClr val="accent1"/>
+          </a:fillRef>
+          <a:effectRef idx="2">
+            <a:schemeClr val="accent1"/>
+          </a:effectRef>
+          <a:fontRef idx="minor">
+            <a:schemeClr val="lt1"/>
+          </a:fontRef>
+        </p:style>
+        <p:txBody>
+          <a:bodyPr rtlCol="0" anchor="ctr"/>
+          <a:lstStyle/>
+          <a:p>
+            <a:pPr algn="ctr"/>
+          </a:p>
+        </p:txBody>
+      </p:sp>
+      <p:sp>
+        <p:nvSpPr>
+          <p:cNvPr id="17452" name="TextBox 17451"/>
+          <p:cNvSpPr txBox="1"/>
+          <p:nvPr/>
+        </p:nvSpPr>
+        <p:spPr>
+          <a:xfrm>
+            <a:off x="10003536" y="5074920"/>
+            <a:ext cx="1737360" cy="256032"/>
+          </a:xfrm>
+          <a:prstGeom prst="rect">
+            <a:avLst/>
+          </a:prstGeom>
+          <a:noFill/>
+        </p:spPr>
+        <p:txBody>
+          <a:bodyPr wrap="square" anchor="t"/>
+          <a:lstStyle/>
+          <a:p>
+            <a:pPr algn="ctr">
+              <a:spcAft>
+                <a:spcPts val="400"/>
+              </a:spcAft>
+            </a:pPr>
+            <a:r>
+              <a:rPr sz="1100" b="1">
+                <a:solidFill>
+                  <a:srgbClr val="0B2E4A"/>
+                </a:solidFill>
+                <a:latin typeface="Arial"/>
+              </a:rPr>
+              <a:t>DigiLocker*</a:t>
+            </a:r>
+          </a:p>
+        </p:txBody>
+      </p:sp>
+      <p:sp>
+        <p:nvSpPr>
+          <p:cNvPr id="17453" name="TextBox 17452"/>
+          <p:cNvSpPr txBox="1"/>
+          <p:nvPr/>
+        </p:nvSpPr>
+        <p:spPr>
+          <a:xfrm>
+            <a:off x="10003536" y="5285232"/>
+            <a:ext cx="1737360" cy="256032"/>
+          </a:xfrm>
+          <a:prstGeom prst="rect">
+            <a:avLst/>
+          </a:prstGeom>
+          <a:noFill/>
+        </p:spPr>
+        <p:txBody>
+          <a:bodyPr wrap="square" anchor="t"/>
+          <a:lstStyle/>
+          <a:p>
+            <a:pPr algn="ctr">
+              <a:spcAft>
+                <a:spcPts val="400"/>
+              </a:spcAft>
+            </a:pPr>
+            <a:r>
+              <a:rPr sz="900" b="0">
+                <a:solidFill>
+                  <a:srgbClr val="3D4A54"/>
+                </a:solidFill>
+                <a:latin typeface="Arial"/>
+              </a:rPr>
+              <a:t>consent pipe</a:t>
+            </a:r>
+          </a:p>
+        </p:txBody>
+      </p:sp>
+      <p:sp>
+        <p:nvSpPr>
+          <p:cNvPr id="17454" name="TextBox 17453"/>
+          <p:cNvSpPr txBox="1"/>
+          <p:nvPr/>
+        </p:nvSpPr>
+        <p:spPr>
+          <a:xfrm>
+            <a:off x="347472" y="5596128"/>
+            <a:ext cx="11430000" cy="502920"/>
+          </a:xfrm>
+          <a:prstGeom prst="rect">
+            <a:avLst/>
+          </a:prstGeom>
+          <a:noFill/>
+        </p:spPr>
+        <p:txBody>
+          <a:bodyPr wrap="square" anchor="t"/>
+          <a:lstStyle/>
+          <a:p>
             <a:pPr algn="l">
               <a:spcAft>
                 <a:spcPts val="400"/>
               </a:spcAft>
             </a:pPr>
             <a:r>
-              <a:rPr sz="1300" b="0">
-                <a:solidFill>
-                  <a:srgbClr val="1A1A1A"/>
+              <a:rPr sz="1100" b="0">
+                <a:solidFill>
+                  <a:srgbClr val="3D4A54"/>
                 </a:solidFill>
                 <a:latin typeface="Arial"/>
               </a:rPr>
-              <a:t>Process: consent + identity link  →  signed 60s grant  →  adapter fetch (live, not stored)  →  canonical map + provenance  →  track / officer / audit.</a:t>
-            </a:r>
-          </a:p>
-          <a:p>
-            <a:pPr algn="l">
-              <a:spcAft>
-                <a:spcPts val="400"/>
-              </a:spcAft>
-            </a:pPr>
-            <a:r>
-              <a:rPr sz="1300" b="0">
-                <a:solidFill>
-                  <a:srgbClr val="1A1A1A"/>
-                </a:solidFill>
-                <a:latin typeface="Arial"/>
-              </a:rPr>
-              <a:t>DigiLocker (production): MeitY partner API after Aadhaar consent lists issued URIs. Departments push copies; locker is not a login into Fire that then dumps 7/12.</a:t>
-            </a:r>
-          </a:p>
-          <a:p>
-            <a:pPr algn="l">
-              <a:spcAft>
-                <a:spcPts val="400"/>
-              </a:spcAft>
-            </a:pPr>
-            <a:r>
-              <a:rPr sz="1300" b="0">
-                <a:solidFill>
-                  <a:srgbClr val="1A1A1A"/>
-                </a:solidFill>
-                <a:latin typeface="Arial"/>
-              </a:rPr>
-              <a:t>Demo now: labelled DigiLocker sandbox + mock issuer adapters. Offline compose. P5 sequence — Journey 1 concrete, Journey 2 generalizes, Journey 3 is config.</a:t>
-            </a:r>
-          </a:p>
-          <a:p>
-            <a:pPr algn="l">
-              <a:spcAft>
-                <a:spcPts val="400"/>
-              </a:spcAft>
-            </a:pPr>
-            <a:r>
-              <a:rPr sz="1300" b="0">
-                <a:solidFill>
-                  <a:srgbClr val="1A1A1A"/>
-                </a:solidFill>
-                <a:latin typeface="Arial"/>
-              </a:rPr>
-              <a:t>Working prototype: three portal skins, officer retry, issued-record papers, tamper-evident audit explorer.</a:t>
+              <a:t>Path: identity link + consent → signed grant → adapter fetch (not stored) → canonical map → track / officer.  *DigiLocker carries issued copies; it is not a department login. Demo uses labelled sandbox + mock adapters.</a:t>
             </a:r>
           </a:p>
         </p:txBody>

</xml_diff>